<commit_message>
fix(make-figures): exclusion boxes use dashed border + left-aligned text
Reviewer feedback after PR #7: visually distinguish exclusion side-branches
from main-flow spine boxes by switching to dashed borders, and reliably
left-align exclusion prose across PowerPoint / LibreOffice / Keynote
(previously relied on inherited default which centered in some viewers).

- `add_box()` now accepts `dash: bool = False` and injects
  `<a:prstDash val="dash"/>` into the line element when set. Reuses the
  module-level lxml/qn imports (deduplicated from the in-function imports
  inside `add_arrow()`).
- Paragraph alignment is now always explicit: `PP_ALIGN.CENTER` for spine /
  stage labels and `PP_ALIGN.LEFT` for exclusions, removing the inherited-
  default ambiguity that produced inconsistent renders.
- The exclusion-rendering loop in `build()` passes `dash=True`.

Exemplar `template_output.pptx` regenerated with the new style.

Co-Authored-By: Claude Opus 4.7 (1M context) <noreply@anthropic.com>
</commit_message>
<xml_diff>
--- a/skills/make-figures/references/exemplar_diagrams/strobe/template_output.pptx
+++ b/skills/make-figures/references/exemplar_diagrams/strobe/template_output.pptx
@@ -3729,6 +3729,7 @@
             <a:solidFill>
               <a:srgbClr val="000000"/>
             </a:solidFill>
+            <a:prstDash val="dash"/>
           </a:ln>
         </p:spPr>
         <p:style>
@@ -3749,7 +3750,7 @@
           <a:bodyPr rtlCol="0" anchor="ctr" wrap="square" tIns="54864" bIns="54864"/>
           <a:lstStyle/>
           <a:p>
-            <a:pPr algn="ctr"/>
+            <a:pPr algn="l"/>
             <a:r>
               <a:rPr sz="1000" b="0">
                 <a:solidFill>
@@ -3760,6 +3761,7 @@
             </a:r>
           </a:p>
           <a:p>
+            <a:pPr algn="l"/>
             <a:r>
               <a:rPr sz="1000" b="0">
                 <a:solidFill>
@@ -3770,6 +3772,7 @@
             </a:r>
           </a:p>
           <a:p>
+            <a:pPr algn="l"/>
             <a:r>
               <a:rPr sz="1000" b="0">
                 <a:solidFill>
@@ -3838,6 +3841,7 @@
             <a:solidFill>
               <a:srgbClr val="000000"/>
             </a:solidFill>
+            <a:prstDash val="dash"/>
           </a:ln>
         </p:spPr>
         <p:style>
@@ -3858,7 +3862,7 @@
           <a:bodyPr rtlCol="0" anchor="ctr" wrap="square" tIns="54864" bIns="54864"/>
           <a:lstStyle/>
           <a:p>
-            <a:pPr algn="ctr"/>
+            <a:pPr algn="l"/>
             <a:r>
               <a:rPr sz="1000" b="0">
                 <a:solidFill>
@@ -3869,6 +3873,7 @@
             </a:r>
           </a:p>
           <a:p>
+            <a:pPr algn="l"/>
             <a:r>
               <a:rPr sz="1000" b="0">
                 <a:solidFill>
@@ -3879,6 +3884,7 @@
             </a:r>
           </a:p>
           <a:p>
+            <a:pPr algn="l"/>
             <a:r>
               <a:rPr sz="1000" b="0">
                 <a:solidFill>

</xml_diff>